<commit_message>
update 6 and 7
</commit_message>
<xml_diff>
--- a/Module6_demographic/6.LifeTablesLeslieMatrices.pptx
+++ b/Module6_demographic/6.LifeTablesLeslieMatrices.pptx
@@ -5,10 +5,10 @@
     <p:sldMasterId id="2147483653" r:id="rId1"/>
   </p:sldMasterIdLst>
   <p:notesMasterIdLst>
-    <p:notesMasterId r:id="rId37"/>
+    <p:notesMasterId r:id="rId38"/>
   </p:notesMasterIdLst>
   <p:handoutMasterIdLst>
-    <p:handoutMasterId r:id="rId38"/>
+    <p:handoutMasterId r:id="rId39"/>
   </p:handoutMasterIdLst>
   <p:sldIdLst>
     <p:sldId id="297" r:id="rId2"/>
@@ -42,10 +42,11 @@
     <p:sldId id="330" r:id="rId30"/>
     <p:sldId id="332" r:id="rId31"/>
     <p:sldId id="333" r:id="rId32"/>
-    <p:sldId id="336" r:id="rId33"/>
-    <p:sldId id="324" r:id="rId34"/>
-    <p:sldId id="294" r:id="rId35"/>
-    <p:sldId id="337" r:id="rId36"/>
+    <p:sldId id="339" r:id="rId33"/>
+    <p:sldId id="336" r:id="rId34"/>
+    <p:sldId id="324" r:id="rId35"/>
+    <p:sldId id="294" r:id="rId36"/>
+    <p:sldId id="337" r:id="rId37"/>
   </p:sldIdLst>
   <p:sldSz cx="9144000" cy="6858000" type="screen4x3"/>
   <p:notesSz cx="7315200" cy="9601200"/>
@@ -207,12 +208,20 @@
 </p:presentation>
 </file>
 
+<file path=ppt/revisionInfo.xml><?xml version="1.0" encoding="utf-8"?>
+<p1510:revInfo xmlns:a="http://schemas.openxmlformats.org/drawingml/2006/main" xmlns:r="http://schemas.openxmlformats.org/officeDocument/2006/relationships" xmlns:p1510="http://schemas.microsoft.com/office/powerpoint/2015/10/main">
+  <p1510:revLst>
+    <p1510:client id="{AD75E69D-7075-489B-B61A-F5DAB412FA31}" v="1" dt="2026-09-10T17:08:28.848"/>
+  </p1510:revLst>
+</p1510:revInfo>
+</file>
+
 <file path=ppt/changesInfos/changesInfo1.xml><?xml version="1.0" encoding="utf-8"?>
 <pc:chgInfo xmlns:a="http://schemas.openxmlformats.org/drawingml/2006/main" xmlns:r="http://schemas.openxmlformats.org/officeDocument/2006/relationships" xmlns:ac="http://schemas.microsoft.com/office/drawing/2013/main/command" xmlns:pc="http://schemas.microsoft.com/office/powerpoint/2013/main/command">
   <pc:docChgLst>
     <pc:chgData name="Babcock, Elizabeth A" userId="02b9ec88-22ae-4f16-80a8-fd6316399148" providerId="ADAL" clId="{CFAE71B8-9659-41D1-BF87-D488A69E897D}"/>
-    <pc:docChg chg="modSld">
-      <pc:chgData name="Babcock, Elizabeth A" userId="02b9ec88-22ae-4f16-80a8-fd6316399148" providerId="ADAL" clId="{CFAE71B8-9659-41D1-BF87-D488A69E897D}" dt="2026-09-08T17:27:12.400" v="0" actId="20577"/>
+    <pc:docChg chg="addSld modSld">
+      <pc:chgData name="Babcock, Elizabeth A" userId="02b9ec88-22ae-4f16-80a8-fd6316399148" providerId="ADAL" clId="{CFAE71B8-9659-41D1-BF87-D488A69E897D}" dt="2026-09-10T17:08:59.118" v="35" actId="14100"/>
       <pc:docMkLst>
         <pc:docMk/>
       </pc:docMkLst>
@@ -230,6 +239,45 @@
             <ac:spMk id="64516" creationId="{00000000-0000-0000-0000-000000000000}"/>
           </ac:spMkLst>
         </pc:spChg>
+      </pc:sldChg>
+      <pc:sldChg chg="addSp delSp modSp new mod">
+        <pc:chgData name="Babcock, Elizabeth A" userId="02b9ec88-22ae-4f16-80a8-fd6316399148" providerId="ADAL" clId="{CFAE71B8-9659-41D1-BF87-D488A69E897D}" dt="2026-09-10T17:08:59.118" v="35" actId="14100"/>
+        <pc:sldMkLst>
+          <pc:docMk/>
+          <pc:sldMk cId="2865451843" sldId="339"/>
+        </pc:sldMkLst>
+        <pc:spChg chg="mod">
+          <ac:chgData name="Babcock, Elizabeth A" userId="02b9ec88-22ae-4f16-80a8-fd6316399148" providerId="ADAL" clId="{CFAE71B8-9659-41D1-BF87-D488A69E897D}" dt="2026-09-10T17:08:04.090" v="24" actId="20577"/>
+          <ac:spMkLst>
+            <pc:docMk/>
+            <pc:sldMk cId="2865451843" sldId="339"/>
+            <ac:spMk id="2" creationId="{A28175A0-0301-D92C-F2CB-9A1399C9B9A3}"/>
+          </ac:spMkLst>
+        </pc:spChg>
+        <pc:spChg chg="del">
+          <ac:chgData name="Babcock, Elizabeth A" userId="02b9ec88-22ae-4f16-80a8-fd6316399148" providerId="ADAL" clId="{CFAE71B8-9659-41D1-BF87-D488A69E897D}" dt="2026-09-10T17:08:28.848" v="25"/>
+          <ac:spMkLst>
+            <pc:docMk/>
+            <pc:sldMk cId="2865451843" sldId="339"/>
+            <ac:spMk id="3" creationId="{A86EEB8D-87FF-2214-04DD-84EBF3020B3B}"/>
+          </ac:spMkLst>
+        </pc:spChg>
+        <pc:picChg chg="add mod">
+          <ac:chgData name="Babcock, Elizabeth A" userId="02b9ec88-22ae-4f16-80a8-fd6316399148" providerId="ADAL" clId="{CFAE71B8-9659-41D1-BF87-D488A69E897D}" dt="2026-09-10T17:08:50.495" v="32" actId="14100"/>
+          <ac:picMkLst>
+            <pc:docMk/>
+            <pc:sldMk cId="2865451843" sldId="339"/>
+            <ac:picMk id="4" creationId="{5B857F27-2688-5949-4A98-51930D575E40}"/>
+          </ac:picMkLst>
+        </pc:picChg>
+        <pc:picChg chg="add mod">
+          <ac:chgData name="Babcock, Elizabeth A" userId="02b9ec88-22ae-4f16-80a8-fd6316399148" providerId="ADAL" clId="{CFAE71B8-9659-41D1-BF87-D488A69E897D}" dt="2026-09-10T17:08:59.118" v="35" actId="14100"/>
+          <ac:picMkLst>
+            <pc:docMk/>
+            <pc:sldMk cId="2865451843" sldId="339"/>
+            <ac:picMk id="5" creationId="{865310A2-85C9-C3F6-8681-CBE4F8FD2D56}"/>
+          </ac:picMkLst>
+        </pc:picChg>
       </pc:sldChg>
     </pc:docChg>
   </pc:docChgLst>
@@ -1177,7 +1225,7 @@
               <a:pPr>
                 <a:defRPr/>
               </a:pPr>
-              <a:t>34</a:t>
+              <a:t>35</a:t>
             </a:fld>
             <a:endParaRPr lang="en-US"/>
           </a:p>
@@ -6345,10 +6393,7 @@
                 </a:pPr>
                 <a14:m>
                   <m:oMathPara xmlns:m="http://schemas.openxmlformats.org/officeDocument/2006/math">
-                    <m:oMathParaPr>
-                      <m:jc m:val="centerGroup"/>
-                    </m:oMathParaPr>
-                    <m:oMath xmlns:m="http://schemas.openxmlformats.org/officeDocument/2006/math">
+                    <m:oMath>
                       <m:sSub>
                         <m:sSubPr>
                           <m:ctrlPr>
@@ -6464,10 +6509,7 @@
                 </a:pPr>
                 <a14:m>
                   <m:oMathPara xmlns:m="http://schemas.openxmlformats.org/officeDocument/2006/math">
-                    <m:oMathParaPr>
-                      <m:jc m:val="centerGroup"/>
-                    </m:oMathParaPr>
-                    <m:oMath xmlns:m="http://schemas.openxmlformats.org/officeDocument/2006/math">
+                    <m:oMath>
                       <m:r>
                         <m:rPr>
                           <m:sty m:val="p"/>
@@ -6707,7 +6749,7 @@
                     <m:sSub>
                       <m:sSubPr>
                         <m:ctrlPr>
-                          <a:rPr lang="en-US" sz="2800" b="0" i="1" smtClean="0">
+                          <a:rPr lang="en-US" sz="2800" b="0" i="0" smtClean="0">
                             <a:latin typeface="Cambria Math" panose="02040503050406030204" pitchFamily="18" charset="0"/>
                           </a:rPr>
                         </m:ctrlPr>
@@ -6904,7 +6946,7 @@
                     <m:sSub>
                       <m:sSubPr>
                         <m:ctrlPr>
-                          <a:rPr lang="en-US" b="0" i="1">
+                          <a:rPr lang="en-US" b="0">
                             <a:latin typeface="Cambria Math" panose="02040503050406030204" pitchFamily="18" charset="0"/>
                           </a:rPr>
                         </m:ctrlPr>
@@ -12837,6 +12879,126 @@
           <p:cNvPr id="2" name="Title 1">
             <a:extLst>
               <a:ext uri="{FF2B5EF4-FFF2-40B4-BE49-F238E27FC236}">
+                <a16:creationId xmlns:a16="http://schemas.microsoft.com/office/drawing/2014/main" id="{A28175A0-0301-D92C-F2CB-9A1399C9B9A3}"/>
+              </a:ext>
+            </a:extLst>
+          </p:cNvPr>
+          <p:cNvSpPr>
+            <a:spLocks noGrp="1"/>
+          </p:cNvSpPr>
+          <p:nvPr>
+            <p:ph type="title"/>
+          </p:nvPr>
+        </p:nvSpPr>
+        <p:spPr/>
+        <p:txBody>
+          <a:bodyPr/>
+          <a:lstStyle/>
+          <a:p>
+            <a:r>
+              <a:rPr lang="en-US" dirty="0"/>
+              <a:t>Distributions</a:t>
+            </a:r>
+          </a:p>
+        </p:txBody>
+      </p:sp>
+      <p:pic>
+        <p:nvPicPr>
+          <p:cNvPr id="4" name="Content Placeholder 3">
+            <a:extLst>
+              <a:ext uri="{FF2B5EF4-FFF2-40B4-BE49-F238E27FC236}">
+                <a16:creationId xmlns:a16="http://schemas.microsoft.com/office/drawing/2014/main" id="{5B857F27-2688-5949-4A98-51930D575E40}"/>
+              </a:ext>
+            </a:extLst>
+          </p:cNvPr>
+          <p:cNvPicPr>
+            <a:picLocks noGrp="1" noChangeAspect="1"/>
+          </p:cNvPicPr>
+          <p:nvPr>
+            <p:ph idx="1"/>
+          </p:nvPr>
+        </p:nvPicPr>
+        <p:blipFill>
+          <a:blip r:embed="rId2"/>
+          <a:stretch>
+            <a:fillRect/>
+          </a:stretch>
+        </p:blipFill>
+        <p:spPr>
+          <a:xfrm>
+            <a:off x="228600" y="914401"/>
+            <a:ext cx="4373881" cy="3124200"/>
+          </a:xfrm>
+          <a:prstGeom prst="rect">
+            <a:avLst/>
+          </a:prstGeom>
+        </p:spPr>
+      </p:pic>
+      <p:pic>
+        <p:nvPicPr>
+          <p:cNvPr id="5" name="Picture 4">
+            <a:extLst>
+              <a:ext uri="{FF2B5EF4-FFF2-40B4-BE49-F238E27FC236}">
+                <a16:creationId xmlns:a16="http://schemas.microsoft.com/office/drawing/2014/main" id="{865310A2-85C9-C3F6-8681-CBE4F8FD2D56}"/>
+              </a:ext>
+            </a:extLst>
+          </p:cNvPr>
+          <p:cNvPicPr>
+            <a:picLocks noChangeAspect="1"/>
+          </p:cNvPicPr>
+          <p:nvPr/>
+        </p:nvPicPr>
+        <p:blipFill>
+          <a:blip r:embed="rId3"/>
+          <a:stretch>
+            <a:fillRect/>
+          </a:stretch>
+        </p:blipFill>
+        <p:spPr>
+          <a:xfrm>
+            <a:off x="4952128" y="914401"/>
+            <a:ext cx="4267199" cy="3047999"/>
+          </a:xfrm>
+          <a:prstGeom prst="rect">
+            <a:avLst/>
+          </a:prstGeom>
+        </p:spPr>
+      </p:pic>
+    </p:spTree>
+    <p:extLst>
+      <p:ext uri="{BB962C8B-B14F-4D97-AF65-F5344CB8AC3E}">
+        <p14:creationId xmlns:p14="http://schemas.microsoft.com/office/powerpoint/2010/main" val="2865451843"/>
+      </p:ext>
+    </p:extLst>
+  </p:cSld>
+  <p:clrMapOvr>
+    <a:masterClrMapping/>
+  </p:clrMapOvr>
+</p:sld>
+</file>
+
+<file path=ppt/slides/slide33.xml><?xml version="1.0" encoding="utf-8"?>
+<p:sld xmlns:a="http://schemas.openxmlformats.org/drawingml/2006/main" xmlns:r="http://schemas.openxmlformats.org/officeDocument/2006/relationships" xmlns:p="http://schemas.openxmlformats.org/presentationml/2006/main">
+  <p:cSld>
+    <p:spTree>
+      <p:nvGrpSpPr>
+        <p:cNvPr id="1" name=""/>
+        <p:cNvGrpSpPr/>
+        <p:nvPr/>
+      </p:nvGrpSpPr>
+      <p:grpSpPr>
+        <a:xfrm>
+          <a:off x="0" y="0"/>
+          <a:ext cx="0" cy="0"/>
+          <a:chOff x="0" y="0"/>
+          <a:chExt cx="0" cy="0"/>
+        </a:xfrm>
+      </p:grpSpPr>
+      <p:sp>
+        <p:nvSpPr>
+          <p:cNvPr id="2" name="Title 1">
+            <a:extLst>
+              <a:ext uri="{FF2B5EF4-FFF2-40B4-BE49-F238E27FC236}">
                 <a16:creationId xmlns:a16="http://schemas.microsoft.com/office/drawing/2014/main" id="{095714C9-2830-8F52-48E1-0DE77A33E6C0}"/>
               </a:ext>
             </a:extLst>
@@ -12960,7 +13122,7 @@
 </p:sld>
 </file>
 
-<file path=ppt/slides/slide33.xml><?xml version="1.0" encoding="utf-8"?>
+<file path=ppt/slides/slide34.xml><?xml version="1.0" encoding="utf-8"?>
 <p:sld xmlns:a="http://schemas.openxmlformats.org/drawingml/2006/main" xmlns:r="http://schemas.openxmlformats.org/officeDocument/2006/relationships" xmlns:p="http://schemas.openxmlformats.org/presentationml/2006/main">
   <p:cSld>
     <p:spTree>
@@ -13070,7 +13232,7 @@
 </p:sld>
 </file>
 
-<file path=ppt/slides/slide34.xml><?xml version="1.0" encoding="utf-8"?>
+<file path=ppt/slides/slide35.xml><?xml version="1.0" encoding="utf-8"?>
 <p:sld xmlns:a="http://schemas.openxmlformats.org/drawingml/2006/main" xmlns:r="http://schemas.openxmlformats.org/officeDocument/2006/relationships" xmlns:p="http://schemas.openxmlformats.org/presentationml/2006/main">
   <p:cSld>
     <p:spTree>
@@ -13497,7 +13659,7 @@
 </p:sld>
 </file>
 
-<file path=ppt/slides/slide35.xml><?xml version="1.0" encoding="utf-8"?>
+<file path=ppt/slides/slide36.xml><?xml version="1.0" encoding="utf-8"?>
 <p:sld xmlns:a="http://schemas.openxmlformats.org/drawingml/2006/main" xmlns:r="http://schemas.openxmlformats.org/officeDocument/2006/relationships" xmlns:p="http://schemas.openxmlformats.org/presentationml/2006/main">
   <p:cSld>
     <p:spTree>
@@ -20057,10 +20219,7 @@
                 </a:pPr>
                 <a14:m>
                   <m:oMathPara xmlns:m="http://schemas.openxmlformats.org/officeDocument/2006/math">
-                    <m:oMathParaPr>
-                      <m:jc m:val="centerGroup"/>
-                    </m:oMathParaPr>
-                    <m:oMath xmlns:m="http://schemas.openxmlformats.org/officeDocument/2006/math">
+                    <m:oMath>
                       <m:r>
                         <a:rPr lang="en-US" b="0" i="1" smtClean="0">
                           <a:latin typeface="Cambria Math" panose="02040503050406030204" pitchFamily="18" charset="0"/>

</xml_diff>